<commit_message>
Permireso punimin pas leximit te plote
</commit_message>
<xml_diff>
--- a/docs/thesis/Prezantimi_Florent_Latifi.pptx
+++ b/docs/thesis/Prezantimi_Florent_Latifi.pptx
@@ -5813,8 +5813,8 @@
         </p:blipFill>
         <p:spPr>
           <a:xfrm>
-            <a:off x="1846837" y="1737360"/>
-            <a:ext cx="8498021" cy="3931920"/>
+            <a:off x="3784982" y="1737360"/>
+            <a:ext cx="4621731" cy="3931920"/>
           </a:xfrm>
           <a:prstGeom prst="rect">
             <a:avLst/>

</xml_diff>

<commit_message>
Perditeso punimin me rezultatet e reja
</commit_message>
<xml_diff>
--- a/docs/thesis/Prezantimi_Florent_Latifi.pptx
+++ b/docs/thesis/Prezantimi_Florent_Latifi.pptx
@@ -4814,7 +4814,7 @@
               </a:defRPr>
             </a:pPr>
             <a:r>
-              <a:t>17 833</a:t>
+              <a:t>15 800</a:t>
             </a:r>
           </a:p>
           <a:p>
@@ -4863,7 +4863,7 @@
               </a:defRPr>
             </a:pPr>
             <a:r>
-              <a:t>3 633</a:t>
+              <a:t>3 532</a:t>
             </a:r>
           </a:p>
           <a:p>
@@ -4912,7 +4912,7 @@
               </a:defRPr>
             </a:pPr>
             <a:r>
-              <a:t>20%</a:t>
+              <a:t>22%</a:t>
             </a:r>
           </a:p>
           <a:p>
@@ -4980,7 +4980,7 @@
               </a:defRPr>
             </a:pPr>
             <a:r>
-              <a:t>·  Arsyeja kryesore është që forma e kodit nuk përputhet — 50% e vendeve.</a:t>
+              <a:t>·  Arsyeja kryesore është që forma e kodit nuk përputhet — 45% e vendeve.</a:t>
             </a:r>
           </a:p>
         </p:txBody>
@@ -5102,7 +5102,7 @@
               </a:defRPr>
             </a:pPr>
             <a:r>
-              <a:t>·  I kompiluar brenda projektit të vet, verdikti më i fortë ngjitet nga 1 te 46 nga 405 rishkrime të mostrës.</a:t>
+              <a:t>·  I kompiluar brenda projektit të vet, verdikti më i fortë ngjitet nga 5 te 66 nga 201 rishkrime të mostrës.</a:t>
             </a:r>
           </a:p>
           <a:p>
@@ -7615,7 +7615,7 @@
                         </a:defRPr>
                       </a:pPr>
                       <a:r>
-                        <a:t>0.500</a:t>
+                        <a:t>0.498</a:t>
                       </a:r>
                     </a:p>
                   </a:txBody>
@@ -7685,7 +7685,7 @@
                         </a:defRPr>
                       </a:pPr>
                       <a:r>
-                        <a:t>0.669</a:t>
+                        <a:t>0.696</a:t>
                       </a:r>
                     </a:p>
                   </a:txBody>
@@ -7755,7 +7755,7 @@
                         </a:defRPr>
                       </a:pPr>
                       <a:r>
-                        <a:t>0.713</a:t>
+                        <a:t>0.724</a:t>
                       </a:r>
                     </a:p>
                   </a:txBody>

</xml_diff>

<commit_message>
Ndreq kapitujt 1-4 sipas komenteve te mentores
Kontributi dhe transformimi i sigurt te Hyrja, dallimi nga studimet te
Hendeku, PK3 sipas asaj qe matet, shkronja e titujve dhe versioni me
kapitujt 1-4 per mentoren (VD-141).
</commit_message>
<xml_diff>
--- a/docs/thesis/Prezantimi_Florent_Latifi.pptx
+++ b/docs/thesis/Prezantimi_Florent_Latifi.pptx
@@ -728,7 +728,7 @@
           <a:lstStyle/>
           <a:p>
             <a:r>
-              <a:t>Përgjigjja e ndarë për PK3 është e qëllimshme dhe e regjistruar te DECISIONS.md.</a:t>
+              <a:t>Formulimi i PK3 u ngushtua me kërkesë të mentores; arsyeja është te DECISIONS.md.</a:t>
             </a:r>
           </a:p>
         </p:txBody>
@@ -1218,7 +1218,7 @@
           <a:lstStyle/>
           <a:p>
             <a:r>
-              <a:t>PK3 ka dy gjysma. Vetëm njëra u mat, dhe kjo thuhet hapur më vonë.</a:t>
+              <a:t>PK3 pyet vetëm për atë që matet: kompilimin dhe heqjen e erës. Ruajtja e sjelljes nuk matet, dhe kjo thuhet hapur më vonë.</a:t>
             </a:r>
           </a:p>
         </p:txBody>
@@ -5047,7 +5047,7 @@
               </a:defRPr>
             </a:pPr>
             <a:r>
-              <a:t>Gjysma e dytë e PK3 nuk u mat</a:t>
+              <a:t>Sjellja nuk matet, ndaj nuk është pjesë e PK3</a:t>
             </a:r>
           </a:p>
         </p:txBody>
@@ -5259,7 +5259,7 @@
               </a:defRPr>
             </a:pPr>
             <a:r>
-              <a:t>·  PK3 — Pjesërisht. Kompilueshmëria u verifikua; sjellja jo, dhe kjo thuhet hapur në vend që pyetja të ngushtohej.</a:t>
+              <a:t>·  PK3 — Pjesërisht. Rishkrimet e aplikuara u verifikuan me kompilator dhe u rimatën; ruajtja e sjelljes mbetet jashtë pyetjes dhe thuhet si kufizim.</a:t>
             </a:r>
           </a:p>
         </p:txBody>
@@ -6095,7 +6095,7 @@
               </a:defRPr>
             </a:pPr>
             <a:r>
-              <a:t>·  PK3 — A i përmirësojnë refaktorimet e propozuara karakteristikat strukturore, duke ruajtur kompilueshmërinë dhe sjelljen?</a:t>
+              <a:t>·  PK3 — A mund të aplikohen automatikisht refaktorimet pa shtuar gabime të reja kompilimi, dhe a e heqin erën sipas rimatjes?</a:t>
             </a:r>
           </a:p>
         </p:txBody>

</xml_diff>

<commit_message>
Korrigjo punimin, ndreq komentet e mentores dhe paketo mjetin në Docker (#3)
Korrektura gjuhësore e punimit (VD-140); komentet e mentores te kapitujt 1–3 dhe versioni me kapitujt 1–4 (VD-141); imazhi Docker me publikim te ghcr.io (VD-142); pritja e kontrastit te testi e2e.
</commit_message>
<xml_diff>
--- a/docs/thesis/Prezantimi_Florent_Latifi.pptx
+++ b/docs/thesis/Prezantimi_Florent_Latifi.pptx
@@ -728,7 +728,7 @@
           <a:lstStyle/>
           <a:p>
             <a:r>
-              <a:t>Përgjigjja e ndarë për PK3 është e qëllimshme dhe e regjistruar te DECISIONS.md.</a:t>
+              <a:t>Formulimi i PK3 u ngushtua me kërkesë të mentores; arsyeja është te DECISIONS.md.</a:t>
             </a:r>
           </a:p>
         </p:txBody>
@@ -1218,7 +1218,7 @@
           <a:lstStyle/>
           <a:p>
             <a:r>
-              <a:t>PK3 ka dy gjysma. Vetëm njëra u mat, dhe kjo thuhet hapur më vonë.</a:t>
+              <a:t>PK3 pyet vetëm për atë që matet: kompilimin dhe heqjen e erës. Ruajtja e sjelljes nuk matet, dhe kjo thuhet hapur më vonë.</a:t>
             </a:r>
           </a:p>
         </p:txBody>
@@ -5047,7 +5047,7 @@
               </a:defRPr>
             </a:pPr>
             <a:r>
-              <a:t>Gjysma e dytë e PK3 nuk u mat</a:t>
+              <a:t>Sjellja nuk matet, ndaj nuk është pjesë e PK3</a:t>
             </a:r>
           </a:p>
         </p:txBody>
@@ -5259,7 +5259,7 @@
               </a:defRPr>
             </a:pPr>
             <a:r>
-              <a:t>·  PK3 — Pjesërisht. Kompilueshmëria u verifikua; sjellja jo, dhe kjo thuhet hapur në vend që pyetja të ngushtohej.</a:t>
+              <a:t>·  PK3 — Pjesërisht. Rishkrimet e aplikuara u verifikuan me kompilator dhe u rimatën; ruajtja e sjelljes mbetet jashtë pyetjes dhe thuhet si kufizim.</a:t>
             </a:r>
           </a:p>
         </p:txBody>
@@ -6095,7 +6095,7 @@
               </a:defRPr>
             </a:pPr>
             <a:r>
-              <a:t>·  PK3 — A i përmirësojnë refaktorimet e propozuara karakteristikat strukturore, duke ruajtur kompilueshmërinë dhe sjelljen?</a:t>
+              <a:t>·  PK3 — A mund të aplikohen automatikisht refaktorimet pa shtuar gabime të reja kompilimi, dhe a e heqin erën sipas rimatjes?</a:t>
             </a:r>
           </a:p>
         </p:txBody>

</xml_diff>

<commit_message>
Përditëso abstraktin, validimin, ndërfaqen dhe prezantimin
Abstrakti merr pranueshmërinë e rishkrimeve dhe mbetet nën 360 fjalë. Te
4.10 numrat e testeve të 8 tetorit (797 dhe 173), te 4.8 mënyra e thjeshtë
dhe te 4.11 imazhi Docker. Prezantimi merr krahasimin me PMD-në, sllajdin
«A ia vlejnë rishkrimet?» dhe saktëson verifikimin dhe kufizimet (VD-147).
</commit_message>
<xml_diff>
--- a/docs/thesis/Prezantimi_Florent_Latifi.pptx
+++ b/docs/thesis/Prezantimi_Florent_Latifi.pptx
@@ -22,6 +22,7 @@
     <p:sldId id="270" r:id="rId22"/>
     <p:sldId id="271" r:id="rId23"/>
     <p:sldId id="272" r:id="rId24"/>
+    <p:sldId id="273" r:id="rId25"/>
   </p:sldIdLst>
   <p:sldSz cx="12191695" cy="6858000" type="screen4x3"/>
   <p:notesSz cx="6858000" cy="9144000"/>
@@ -728,7 +729,7 @@
           <a:lstStyle/>
           <a:p>
             <a:r>
-              <a:t>Formulimi i PK3 u ngushtua me kërkesë të mentores; arsyeja është te DECISIONS.md.</a:t>
+              <a:t>Guard Clauses 100%, Extract Method 65%, Introduce Parameter Object 0%. Extract Method do emër tjetër në vend të «extracted»; një rishkrim i tij nuk kompilon, ndonëse kishte verdiktin «pa gabim të ri» — gabimi ishte i të njëjtit lloj si ata që skedari i izoluar kishte tashmë.</a:t>
             </a:r>
           </a:p>
         </p:txBody>
@@ -798,7 +799,7 @@
           <a:lstStyle/>
           <a:p>
             <a:r>
-              <a:t>Më mirë t'i thuash vetë kufizimet se t'i nxjerrin ata.</a:t>
+              <a:t>Formulimi i PK3 u ngushtua me kërkesë të mentores; arsyeja është te DECISIONS.md.</a:t>
             </a:r>
           </a:p>
         </p:txBody>
@@ -868,7 +869,7 @@
           <a:lstStyle/>
           <a:p>
             <a:r>
-              <a:t>Mbyll me riprodhueshmërinë: është ajo që e dallon këtë punim.</a:t>
+              <a:t>Më mirë t'i thuash vetë kufizimet se t'i nxjerrin ata.</a:t>
             </a:r>
           </a:p>
         </p:txBody>
@@ -938,7 +939,7 @@
           <a:lstStyle/>
           <a:p>
             <a:r>
-              <a:t>Sllajdet rezervë vijnë pas kësaj.</a:t>
+              <a:t>Mbyll me riprodhueshmërinë: është ajo që e dallon këtë punim.</a:t>
             </a:r>
           </a:p>
         </p:txBody>
@@ -1008,7 +1009,7 @@
           <a:lstStyle/>
           <a:p>
             <a:r>
-              <a:t>Fshirja mat qëndrueshmëri, nuk zgjedh pragje. Dy pragje dolën të ndjeshme dhe nuk u adoptuan.</a:t>
+              <a:t>Sllajdet rezervë vijnë pas kësaj.</a:t>
             </a:r>
           </a:p>
         </p:txBody>
@@ -1034,6 +1035,76 @@
 </file>
 
 <file path=ppt/notesSlides/notesSlide17.xml><?xml version="1.0" encoding="utf-8"?>
+<p:notes xmlns:a="http://schemas.openxmlformats.org/drawingml/2006/main" xmlns:p="http://schemas.openxmlformats.org/presentationml/2006/main" xmlns:r="http://schemas.openxmlformats.org/officeDocument/2006/relationships">
+  <p:cSld>
+    <p:spTree>
+      <p:nvGrpSpPr>
+        <p:cNvPr id="1" name=""/>
+        <p:cNvGrpSpPr/>
+        <p:nvPr/>
+      </p:nvGrpSpPr>
+      <p:grpSpPr>
+        <a:xfrm>
+          <a:off x="0" y="0"/>
+          <a:ext cx="0" cy="0"/>
+          <a:chOff x="0" y="0"/>
+          <a:chExt cx="0" cy="0"/>
+        </a:xfrm>
+      </p:grpSpPr>
+      <p:sp>
+        <p:nvSpPr>
+          <p:cNvPr id="2" name="Slide Image Placeholder 1"/>
+          <p:cNvSpPr>
+            <a:spLocks noGrp="1"/>
+          </p:cNvSpPr>
+          <p:nvPr>
+            <p:ph type="sldImg" idx="2"/>
+          </p:nvPr>
+        </p:nvSpPr>
+        <p:spPr/>
+      </p:sp>
+      <p:sp>
+        <p:nvSpPr>
+          <p:cNvPr id="3" name="Notes Placeholder 2"/>
+          <p:cNvSpPr>
+            <a:spLocks noGrp="1"/>
+          </p:cNvSpPr>
+          <p:nvPr>
+            <p:ph type="body" idx="3" sz="quarter"/>
+          </p:nvPr>
+        </p:nvSpPr>
+        <p:spPr/>
+        <p:txBody>
+          <a:bodyPr/>
+          <a:lstStyle/>
+          <a:p>
+            <a:r>
+              <a:t>Fshirja mat qëndrueshmëri, nuk zgjedh pragje. Dy pragje dolën të ndjeshme dhe nuk u adoptuan.</a:t>
+            </a:r>
+          </a:p>
+        </p:txBody>
+      </p:sp>
+      <p:sp>
+        <p:nvSpPr>
+          <p:cNvPr id="4" name="Slide Number Placeholder 3"/>
+          <p:cNvSpPr>
+            <a:spLocks noGrp="1"/>
+          </p:cNvSpPr>
+          <p:nvPr>
+            <p:ph type="sldNum" idx="5" sz="quarter"/>
+          </p:nvPr>
+        </p:nvSpPr>
+        <p:spPr/>
+      </p:sp>
+    </p:spTree>
+  </p:cSld>
+  <p:clrMapOvr>
+    <a:masterClrMapping/>
+  </p:clrMapOvr>
+</p:notes>
+</file>
+
+<file path=ppt/notesSlides/notesSlide18.xml><?xml version="1.0" encoding="utf-8"?>
 <p:notes xmlns:a="http://schemas.openxmlformats.org/drawingml/2006/main" xmlns:p="http://schemas.openxmlformats.org/presentationml/2006/main" xmlns:r="http://schemas.openxmlformats.org/officeDocument/2006/relationships">
   <p:cSld>
     <p:spTree>
@@ -5086,7 +5157,7 @@
               </a:defRPr>
             </a:pPr>
             <a:r>
-              <a:t>·  Çdo rishkrim kompilohet. Pretendimi është «kompilon» ose «nuk shton lloj të ri gabimi».</a:t>
+              <a:t>·  Çdo rishkrim kalon nga javac. Pretendimi është «kompilon» ose «nuk shton lloj të ri gabimi», dhe i dyti nuk është garanci.</a:t>
             </a:r>
           </a:p>
           <a:p>
@@ -5188,20 +5259,57 @@
               </a:defRPr>
             </a:pPr>
             <a:r>
-              <a:t>Përgjigjet</a:t>
-            </a:r>
-          </a:p>
-        </p:txBody>
-      </p:sp>
-      <p:sp>
-        <p:nvSpPr>
-          <p:cNvPr id="3" name="TextBox 2"/>
+              <a:t>A ia vlejnë rishkrimet?</a:t>
+            </a:r>
+          </a:p>
+          <a:p>
+            <a:pPr>
+              <a:defRPr sz="1400">
+                <a:solidFill>
+                  <a:srgbClr val="838D99"/>
+                </a:solidFill>
+                <a:latin typeface="Segoe UI"/>
+              </a:defRPr>
+            </a:pPr>
+            <a:r>
+              <a:t>60 rishkrime të lexuara sipas një rubrike, pa parë verdiktin e kompilatorit</a:t>
+            </a:r>
+          </a:p>
+        </p:txBody>
+      </p:sp>
+      <p:pic>
+        <p:nvPicPr>
+          <p:cNvPr id="3" name="Picture 2" descr="pranueshmeria_e_rishkrimeve.png"/>
+          <p:cNvPicPr>
+            <a:picLocks noChangeAspect="1"/>
+          </p:cNvPicPr>
+          <p:nvPr/>
+        </p:nvPicPr>
+        <p:blipFill>
+          <a:blip r:embed="rId2"/>
+          <a:stretch>
+            <a:fillRect/>
+          </a:stretch>
+        </p:blipFill>
+        <p:spPr>
+          <a:xfrm>
+            <a:off x="2565333" y="1737360"/>
+            <a:ext cx="7061028" cy="3108960"/>
+          </a:xfrm>
+          <a:prstGeom prst="rect">
+            <a:avLst/>
+          </a:prstGeom>
+        </p:spPr>
+      </p:pic>
+      <p:sp>
+        <p:nvSpPr>
+          <p:cNvPr id="4" name="TextBox 3"/>
           <p:cNvSpPr txBox="1"/>
           <p:nvPr/>
         </p:nvSpPr>
         <p:spPr>
           <a:xfrm>
-            <a:off x="777240" y="1737360"/>
+            <a:off x="777240" y="4937760"/>
             <a:ext cx="10637215" cy="4206240"/>
           </a:xfrm>
           <a:prstGeom prst="rect">
@@ -5219,7 +5327,7 @@
               <a:spcAft>
                 <a:spcPts val="1400"/>
               </a:spcAft>
-              <a:defRPr sz="1900" b="0">
+              <a:defRPr sz="1400" b="0">
                 <a:solidFill>
                   <a:srgbClr val="1A1D21"/>
                 </a:solidFill>
@@ -5227,7 +5335,7 @@
               </a:defRPr>
             </a:pPr>
             <a:r>
-              <a:t>·  PK1 — Strategjitë janë të sakta kur ndezin, por e humbin shumicën e rasteve.</a:t>
+              <a:t>·  Të ripeshuara: 63% të pranueshme për një zhvillues, zakonisht pas një ndreqjeje të vogël.</a:t>
             </a:r>
           </a:p>
           <a:p>
@@ -5235,7 +5343,7 @@
               <a:spcAft>
                 <a:spcPts val="1400"/>
               </a:spcAft>
-              <a:defRPr sz="1900">
+              <a:defRPr sz="1400">
                 <a:solidFill>
                   <a:srgbClr val="1A1D21"/>
                 </a:solidFill>
@@ -5243,23 +5351,7 @@
               </a:defRPr>
             </a:pPr>
             <a:r>
-              <a:t>·  PK2 — Po. Modeli i tejkalon pragjet fikse te të katër erërat, mbi të njëjtën ndarje dhe me të njëjtin kod pikëzimi.</a:t>
-            </a:r>
-          </a:p>
-          <a:p>
-            <a:pPr>
-              <a:spcAft>
-                <a:spcPts val="1400"/>
-              </a:spcAft>
-              <a:defRPr sz="1900">
-                <a:solidFill>
-                  <a:srgbClr val="1A1D21"/>
-                </a:solidFill>
-                <a:latin typeface="Segoe UI"/>
-              </a:defRPr>
-            </a:pPr>
-            <a:r>
-              <a:t>·  PK3 — Pjesërisht. Rishkrimet e aplikuara u verifikuan me kompilator dhe u rimatën; ruajtja e sjelljes mbetet jashtë pyetjes dhe thuhet si kufizim.</a:t>
+              <a:t>·  Introduce Parameter Object e heq erën nga matja, jo nga kodi: lista e gjatë kalon te konstruktori.</a:t>
             </a:r>
           </a:p>
         </p:txBody>
@@ -5313,20 +5405,7 @@
               </a:defRPr>
             </a:pPr>
             <a:r>
-              <a:t>Kufizimet</a:t>
-            </a:r>
-          </a:p>
-          <a:p>
-            <a:pPr>
-              <a:defRPr sz="1400">
-                <a:solidFill>
-                  <a:srgbClr val="838D99"/>
-                </a:solidFill>
-                <a:latin typeface="Segoe UI"/>
-              </a:defRPr>
-            </a:pPr>
-            <a:r>
-              <a:t>Të raportuara, jo të zbutura</a:t>
+              <a:t>Përgjigjet</a:t>
             </a:r>
           </a:p>
         </p:txBody>
@@ -5365,7 +5444,7 @@
               </a:defRPr>
             </a:pPr>
             <a:r>
-              <a:t>·  E vërteta bazë është subjektive dhe rishikuesit nuk pajtohen mes tyre.</a:t>
+              <a:t>·  PK1 — Strategjitë janë të sakta kur ndezin, por e humbin shumicën e rasteve.</a:t>
             </a:r>
           </a:p>
           <a:p>
@@ -5381,7 +5460,7 @@
               </a:defRPr>
             </a:pPr>
             <a:r>
-              <a:t>·  Analiza është statike dhe nuk zgjidh tipa: varësitë semantike trajtohen konservativisht.</a:t>
+              <a:t>·  PK2 — Po. Modeli i tejkalon pragjet fikse te të katër erërat, mbi të njëjtën ndarje dhe me të njëjtin kod pikëzimi.</a:t>
             </a:r>
           </a:p>
           <a:p>
@@ -5397,39 +5476,7 @@
               </a:defRPr>
             </a:pPr>
             <a:r>
-              <a:t>·  Ashpërsia e derivuar u krahasua me atë të rishikuesve, rezultati doli negativ, dhe pretendimi u hoq.</a:t>
-            </a:r>
-          </a:p>
-          <a:p>
-            <a:pPr>
-              <a:spcAft>
-                <a:spcPts val="1400"/>
-              </a:spcAft>
-              <a:defRPr sz="1900">
-                <a:solidFill>
-                  <a:srgbClr val="1A1D21"/>
-                </a:solidFill>
-                <a:latin typeface="Segoe UI"/>
-              </a:defRPr>
-            </a:pPr>
-            <a:r>
-              <a:t>·  Sjellja e kodit të rishkruar mbetet e paverifikuar.</a:t>
-            </a:r>
-          </a:p>
-          <a:p>
-            <a:pPr>
-              <a:spcAft>
-                <a:spcPts val="1400"/>
-              </a:spcAft>
-              <a:defRPr sz="1900">
-                <a:solidFill>
-                  <a:srgbClr val="1A1D21"/>
-                </a:solidFill>
-                <a:latin typeface="Segoe UI"/>
-              </a:defRPr>
-            </a:pPr>
-            <a:r>
-              <a:t>·  Nuk ka krahasim me mjete ekzistuese: kontributi është krahasueshmëria e brendshme mes A-së dhe B-së.</a:t>
+              <a:t>·  PK3 — Pjesërisht. Rishkrimet u verifikuan me kompilator dhe u rimatën; struktura përmirësohet te Guard Clauses dhe Extract Method, jo te Introduce Parameter Object. Sjellja nuk u mat.</a:t>
             </a:r>
           </a:p>
         </p:txBody>
@@ -5483,7 +5530,20 @@
               </a:defRPr>
             </a:pPr>
             <a:r>
-              <a:t>Kontributi</a:t>
+              <a:t>Kufizimet</a:t>
+            </a:r>
+          </a:p>
+          <a:p>
+            <a:pPr>
+              <a:defRPr sz="1400">
+                <a:solidFill>
+                  <a:srgbClr val="838D99"/>
+                </a:solidFill>
+                <a:latin typeface="Segoe UI"/>
+              </a:defRPr>
+            </a:pPr>
+            <a:r>
+              <a:t>Të raportuara, jo të zbutura</a:t>
             </a:r>
           </a:p>
         </p:txBody>
@@ -5522,7 +5582,7 @@
               </a:defRPr>
             </a:pPr>
             <a:r>
-              <a:t>·  Dy qasje detektimi të vlerësuara mbi të njëjtin korpus me të njëjtin kod pikëzimi, me ndarje të grupuar dhe të deklaruar.</a:t>
+              <a:t>·  E vërteta bazë është subjektive dhe rishikuesit nuk pajtohen mes tyre.</a:t>
             </a:r>
           </a:p>
           <a:p>
@@ -5538,7 +5598,7 @@
               </a:defRPr>
             </a:pPr>
             <a:r>
-              <a:t>·  Lidhja mes detektimit dhe refaktorimit e matur empirikisht: sa nga rastet e gjetura arrijnë të transformohen vërtet.</a:t>
+              <a:t>·  Analiza është statike dhe nuk zgjidh tipa: varësitë semantike trajtohen konservativisht.</a:t>
             </a:r>
           </a:p>
           <a:p>
@@ -5554,7 +5614,7 @@
               </a:defRPr>
             </a:pPr>
             <a:r>
-              <a:t>·  Rezultatet negative të raportuara, jo të fshehura.</a:t>
+              <a:t>·  Ashpërsia e derivuar u krahasua me atë të rishikuesve, rezultati doli negativ, dhe pretendimi u hoq.</a:t>
             </a:r>
           </a:p>
           <a:p>
@@ -5570,7 +5630,23 @@
               </a:defRPr>
             </a:pPr>
             <a:r>
-              <a:t>·  Çdo shifër e riprodhueshme nga një skript, dhe riprodhimi u vu në provë.</a:t>
+              <a:t>·  Sjellja e kodit të rishkruar mbetet e paverifikuar.</a:t>
+            </a:r>
+          </a:p>
+          <a:p>
+            <a:pPr>
+              <a:spcAft>
+                <a:spcPts val="1400"/>
+              </a:spcAft>
+              <a:defRPr sz="1900">
+                <a:solidFill>
+                  <a:srgbClr val="1A1D21"/>
+                </a:solidFill>
+                <a:latin typeface="Segoe UI"/>
+              </a:defRPr>
+            </a:pPr>
+            <a:r>
+              <a:t>·  Cilësia e rishkrimeve u gjykua nga një rishikues i vetëm.</a:t>
             </a:r>
           </a:p>
         </p:txBody>
@@ -5601,6 +5677,147 @@
         </p:nvSpPr>
         <p:spPr>
           <a:xfrm>
+            <a:off x="777240" y="457200"/>
+            <a:ext cx="10637215" cy="914400"/>
+          </a:xfrm>
+          <a:prstGeom prst="rect">
+            <a:avLst/>
+          </a:prstGeom>
+          <a:noFill/>
+        </p:spPr>
+        <p:txBody>
+          <a:bodyPr wrap="square">
+            <a:spAutoFit/>
+          </a:bodyPr>
+          <a:lstStyle/>
+          <a:p>
+            <a:pPr>
+              <a:defRPr sz="3400" b="0">
+                <a:solidFill>
+                  <a:srgbClr val="1A1D21"/>
+                </a:solidFill>
+                <a:latin typeface="Times New Roman"/>
+              </a:defRPr>
+            </a:pPr>
+            <a:r>
+              <a:t>Kontributi</a:t>
+            </a:r>
+          </a:p>
+        </p:txBody>
+      </p:sp>
+      <p:sp>
+        <p:nvSpPr>
+          <p:cNvPr id="3" name="TextBox 2"/>
+          <p:cNvSpPr txBox="1"/>
+          <p:nvPr/>
+        </p:nvSpPr>
+        <p:spPr>
+          <a:xfrm>
+            <a:off x="777240" y="1737360"/>
+            <a:ext cx="10637215" cy="4206240"/>
+          </a:xfrm>
+          <a:prstGeom prst="rect">
+            <a:avLst/>
+          </a:prstGeom>
+          <a:noFill/>
+        </p:spPr>
+        <p:txBody>
+          <a:bodyPr wrap="square">
+            <a:spAutoFit/>
+          </a:bodyPr>
+          <a:lstStyle/>
+          <a:p>
+            <a:pPr>
+              <a:spcAft>
+                <a:spcPts val="1400"/>
+              </a:spcAft>
+              <a:defRPr sz="1900" b="0">
+                <a:solidFill>
+                  <a:srgbClr val="1A1D21"/>
+                </a:solidFill>
+                <a:latin typeface="Segoe UI"/>
+              </a:defRPr>
+            </a:pPr>
+            <a:r>
+              <a:t>·  Dy qasje detektimi të vlerësuara mbi të njëjtin korpus me të njëjtin kod pikëzimi, me ndarje të grupuar dhe të deklaruar.</a:t>
+            </a:r>
+          </a:p>
+          <a:p>
+            <a:pPr>
+              <a:spcAft>
+                <a:spcPts val="1400"/>
+              </a:spcAft>
+              <a:defRPr sz="1900">
+                <a:solidFill>
+                  <a:srgbClr val="1A1D21"/>
+                </a:solidFill>
+                <a:latin typeface="Segoe UI"/>
+              </a:defRPr>
+            </a:pPr>
+            <a:r>
+              <a:t>·  Lidhja mes detektimit dhe refaktorimit e matur empirikisht: sa nga rastet e gjetura arrijnë të transformohen vërtet.</a:t>
+            </a:r>
+          </a:p>
+          <a:p>
+            <a:pPr>
+              <a:spcAft>
+                <a:spcPts val="1400"/>
+              </a:spcAft>
+              <a:defRPr sz="1900">
+                <a:solidFill>
+                  <a:srgbClr val="1A1D21"/>
+                </a:solidFill>
+                <a:latin typeface="Segoe UI"/>
+              </a:defRPr>
+            </a:pPr>
+            <a:r>
+              <a:t>·  Rezultatet negative të raportuara, jo të fshehura.</a:t>
+            </a:r>
+          </a:p>
+          <a:p>
+            <a:pPr>
+              <a:spcAft>
+                <a:spcPts val="1400"/>
+              </a:spcAft>
+              <a:defRPr sz="1900">
+                <a:solidFill>
+                  <a:srgbClr val="1A1D21"/>
+                </a:solidFill>
+                <a:latin typeface="Segoe UI"/>
+              </a:defRPr>
+            </a:pPr>
+            <a:r>
+              <a:t>·  Çdo shifër e riprodhueshme nga një skript, dhe riprodhimi u vu në provë.</a:t>
+            </a:r>
+          </a:p>
+        </p:txBody>
+      </p:sp>
+    </p:spTree>
+  </p:cSld>
+  <p:clrMapOvr>
+    <a:masterClrMapping/>
+  </p:clrMapOvr>
+</p:sld>
+</file>
+
+<file path=ppt/slides/slide16.xml><?xml version="1.0" encoding="utf-8"?>
+<p:sld xmlns:a="http://schemas.openxmlformats.org/drawingml/2006/main" xmlns:p="http://schemas.openxmlformats.org/presentationml/2006/main" xmlns:r="http://schemas.openxmlformats.org/officeDocument/2006/relationships">
+  <p:cSld>
+    <p:spTree>
+      <p:nvGrpSpPr>
+        <p:cNvPr id="1" name=""/>
+        <p:cNvGrpSpPr/>
+        <p:nvPr/>
+      </p:nvGrpSpPr>
+      <p:grpSpPr/>
+      <p:sp>
+        <p:nvSpPr>
+          <p:cNvPr id="2" name="TextBox 1"/>
+          <p:cNvSpPr txBox="1"/>
+          <p:nvPr/>
+        </p:nvSpPr>
+        <p:spPr>
+          <a:xfrm>
             <a:off x="777240" y="2743200"/>
             <a:ext cx="10637215" cy="914400"/>
           </a:xfrm>
@@ -5673,7 +5890,7 @@
 </p:sld>
 </file>
 
-<file path=ppt/slides/slide16.xml><?xml version="1.0" encoding="utf-8"?>
+<file path=ppt/slides/slide17.xml><?xml version="1.0" encoding="utf-8"?>
 <p:sld xmlns:a="http://schemas.openxmlformats.org/drawingml/2006/main" xmlns:p="http://schemas.openxmlformats.org/presentationml/2006/main" xmlns:r="http://schemas.openxmlformats.org/officeDocument/2006/relationships">
   <p:cSld>
     <p:spTree>
@@ -5751,7 +5968,7 @@
 </p:sld>
 </file>
 
-<file path=ppt/slides/slide17.xml><?xml version="1.0" encoding="utf-8"?>
+<file path=ppt/slides/slide18.xml><?xml version="1.0" encoding="utf-8"?>
 <p:sld xmlns:a="http://schemas.openxmlformats.org/drawingml/2006/main" xmlns:p="http://schemas.openxmlformats.org/presentationml/2006/main" xmlns:r="http://schemas.openxmlformats.org/officeDocument/2006/relationships">
   <p:cSld>
     <p:spTree>
@@ -7243,6 +7460,22 @@
             </a:pPr>
             <a:r>
               <a:t>·  Kur strategjia ndez, zakonisht ka të drejtë. Por ndez rrallë.</a:t>
+            </a:r>
+          </a:p>
+          <a:p>
+            <a:pPr>
+              <a:spcAft>
+                <a:spcPts val="1400"/>
+              </a:spcAft>
+              <a:defRPr sz="1400">
+                <a:solidFill>
+                  <a:srgbClr val="1A1D21"/>
+                </a:solidFill>
+                <a:latin typeface="Segoe UI"/>
+              </a:defRPr>
+            </a:pPr>
+            <a:r>
+              <a:t>·  PMD-ja, me të njëjtat strategji dhe pragjet e veta, nuk del më mirë në asnjë krahasim.</a:t>
             </a:r>
           </a:p>
         </p:txBody>

</xml_diff>

<commit_message>
Përditëso abstraktin, validimin, ndërfaqen dhe prezantimin (#8)
Abstrakti merr pranueshmërinë e rishkrimeve dhe mbetet nën 360 fjalë. Te
4.10 numrat e testeve të 8 tetorit (797 dhe 173), te 4.8 mënyra e thjeshtë
dhe te 4.11 imazhi Docker. Prezantimi merr krahasimin me PMD-në, sllajdin
«A ia vlejnë rishkrimet?» dhe saktëson verifikimin dhe kufizimet (VD-147).
</commit_message>
<xml_diff>
--- a/docs/thesis/Prezantimi_Florent_Latifi.pptx
+++ b/docs/thesis/Prezantimi_Florent_Latifi.pptx
@@ -22,6 +22,7 @@
     <p:sldId id="270" r:id="rId22"/>
     <p:sldId id="271" r:id="rId23"/>
     <p:sldId id="272" r:id="rId24"/>
+    <p:sldId id="273" r:id="rId25"/>
   </p:sldIdLst>
   <p:sldSz cx="12191695" cy="6858000" type="screen4x3"/>
   <p:notesSz cx="6858000" cy="9144000"/>
@@ -728,7 +729,7 @@
           <a:lstStyle/>
           <a:p>
             <a:r>
-              <a:t>Formulimi i PK3 u ngushtua me kërkesë të mentores; arsyeja është te DECISIONS.md.</a:t>
+              <a:t>Guard Clauses 100%, Extract Method 65%, Introduce Parameter Object 0%. Extract Method do emër tjetër në vend të «extracted»; një rishkrim i tij nuk kompilon, ndonëse kishte verdiktin «pa gabim të ri» — gabimi ishte i të njëjtit lloj si ata që skedari i izoluar kishte tashmë.</a:t>
             </a:r>
           </a:p>
         </p:txBody>
@@ -798,7 +799,7 @@
           <a:lstStyle/>
           <a:p>
             <a:r>
-              <a:t>Më mirë t'i thuash vetë kufizimet se t'i nxjerrin ata.</a:t>
+              <a:t>Formulimi i PK3 u ngushtua me kërkesë të mentores; arsyeja është te DECISIONS.md.</a:t>
             </a:r>
           </a:p>
         </p:txBody>
@@ -868,7 +869,7 @@
           <a:lstStyle/>
           <a:p>
             <a:r>
-              <a:t>Mbyll me riprodhueshmërinë: është ajo që e dallon këtë punim.</a:t>
+              <a:t>Më mirë t'i thuash vetë kufizimet se t'i nxjerrin ata.</a:t>
             </a:r>
           </a:p>
         </p:txBody>
@@ -938,7 +939,7 @@
           <a:lstStyle/>
           <a:p>
             <a:r>
-              <a:t>Sllajdet rezervë vijnë pas kësaj.</a:t>
+              <a:t>Mbyll me riprodhueshmërinë: është ajo që e dallon këtë punim.</a:t>
             </a:r>
           </a:p>
         </p:txBody>
@@ -1008,7 +1009,7 @@
           <a:lstStyle/>
           <a:p>
             <a:r>
-              <a:t>Fshirja mat qëndrueshmëri, nuk zgjedh pragje. Dy pragje dolën të ndjeshme dhe nuk u adoptuan.</a:t>
+              <a:t>Sllajdet rezervë vijnë pas kësaj.</a:t>
             </a:r>
           </a:p>
         </p:txBody>
@@ -1034,6 +1035,76 @@
 </file>
 
 <file path=ppt/notesSlides/notesSlide17.xml><?xml version="1.0" encoding="utf-8"?>
+<p:notes xmlns:a="http://schemas.openxmlformats.org/drawingml/2006/main" xmlns:p="http://schemas.openxmlformats.org/presentationml/2006/main" xmlns:r="http://schemas.openxmlformats.org/officeDocument/2006/relationships">
+  <p:cSld>
+    <p:spTree>
+      <p:nvGrpSpPr>
+        <p:cNvPr id="1" name=""/>
+        <p:cNvGrpSpPr/>
+        <p:nvPr/>
+      </p:nvGrpSpPr>
+      <p:grpSpPr>
+        <a:xfrm>
+          <a:off x="0" y="0"/>
+          <a:ext cx="0" cy="0"/>
+          <a:chOff x="0" y="0"/>
+          <a:chExt cx="0" cy="0"/>
+        </a:xfrm>
+      </p:grpSpPr>
+      <p:sp>
+        <p:nvSpPr>
+          <p:cNvPr id="2" name="Slide Image Placeholder 1"/>
+          <p:cNvSpPr>
+            <a:spLocks noGrp="1"/>
+          </p:cNvSpPr>
+          <p:nvPr>
+            <p:ph type="sldImg" idx="2"/>
+          </p:nvPr>
+        </p:nvSpPr>
+        <p:spPr/>
+      </p:sp>
+      <p:sp>
+        <p:nvSpPr>
+          <p:cNvPr id="3" name="Notes Placeholder 2"/>
+          <p:cNvSpPr>
+            <a:spLocks noGrp="1"/>
+          </p:cNvSpPr>
+          <p:nvPr>
+            <p:ph type="body" idx="3" sz="quarter"/>
+          </p:nvPr>
+        </p:nvSpPr>
+        <p:spPr/>
+        <p:txBody>
+          <a:bodyPr/>
+          <a:lstStyle/>
+          <a:p>
+            <a:r>
+              <a:t>Fshirja mat qëndrueshmëri, nuk zgjedh pragje. Dy pragje dolën të ndjeshme dhe nuk u adoptuan.</a:t>
+            </a:r>
+          </a:p>
+        </p:txBody>
+      </p:sp>
+      <p:sp>
+        <p:nvSpPr>
+          <p:cNvPr id="4" name="Slide Number Placeholder 3"/>
+          <p:cNvSpPr>
+            <a:spLocks noGrp="1"/>
+          </p:cNvSpPr>
+          <p:nvPr>
+            <p:ph type="sldNum" idx="5" sz="quarter"/>
+          </p:nvPr>
+        </p:nvSpPr>
+        <p:spPr/>
+      </p:sp>
+    </p:spTree>
+  </p:cSld>
+  <p:clrMapOvr>
+    <a:masterClrMapping/>
+  </p:clrMapOvr>
+</p:notes>
+</file>
+
+<file path=ppt/notesSlides/notesSlide18.xml><?xml version="1.0" encoding="utf-8"?>
 <p:notes xmlns:a="http://schemas.openxmlformats.org/drawingml/2006/main" xmlns:p="http://schemas.openxmlformats.org/presentationml/2006/main" xmlns:r="http://schemas.openxmlformats.org/officeDocument/2006/relationships">
   <p:cSld>
     <p:spTree>
@@ -5086,7 +5157,7 @@
               </a:defRPr>
             </a:pPr>
             <a:r>
-              <a:t>·  Çdo rishkrim kompilohet. Pretendimi është «kompilon» ose «nuk shton lloj të ri gabimi».</a:t>
+              <a:t>·  Çdo rishkrim kalon nga javac. Pretendimi është «kompilon» ose «nuk shton lloj të ri gabimi», dhe i dyti nuk është garanci.</a:t>
             </a:r>
           </a:p>
           <a:p>
@@ -5188,20 +5259,57 @@
               </a:defRPr>
             </a:pPr>
             <a:r>
-              <a:t>Përgjigjet</a:t>
-            </a:r>
-          </a:p>
-        </p:txBody>
-      </p:sp>
-      <p:sp>
-        <p:nvSpPr>
-          <p:cNvPr id="3" name="TextBox 2"/>
+              <a:t>A ia vlejnë rishkrimet?</a:t>
+            </a:r>
+          </a:p>
+          <a:p>
+            <a:pPr>
+              <a:defRPr sz="1400">
+                <a:solidFill>
+                  <a:srgbClr val="838D99"/>
+                </a:solidFill>
+                <a:latin typeface="Segoe UI"/>
+              </a:defRPr>
+            </a:pPr>
+            <a:r>
+              <a:t>60 rishkrime të lexuara sipas një rubrike, pa parë verdiktin e kompilatorit</a:t>
+            </a:r>
+          </a:p>
+        </p:txBody>
+      </p:sp>
+      <p:pic>
+        <p:nvPicPr>
+          <p:cNvPr id="3" name="Picture 2" descr="pranueshmeria_e_rishkrimeve.png"/>
+          <p:cNvPicPr>
+            <a:picLocks noChangeAspect="1"/>
+          </p:cNvPicPr>
+          <p:nvPr/>
+        </p:nvPicPr>
+        <p:blipFill>
+          <a:blip r:embed="rId2"/>
+          <a:stretch>
+            <a:fillRect/>
+          </a:stretch>
+        </p:blipFill>
+        <p:spPr>
+          <a:xfrm>
+            <a:off x="2565333" y="1737360"/>
+            <a:ext cx="7061028" cy="3108960"/>
+          </a:xfrm>
+          <a:prstGeom prst="rect">
+            <a:avLst/>
+          </a:prstGeom>
+        </p:spPr>
+      </p:pic>
+      <p:sp>
+        <p:nvSpPr>
+          <p:cNvPr id="4" name="TextBox 3"/>
           <p:cNvSpPr txBox="1"/>
           <p:nvPr/>
         </p:nvSpPr>
         <p:spPr>
           <a:xfrm>
-            <a:off x="777240" y="1737360"/>
+            <a:off x="777240" y="4937760"/>
             <a:ext cx="10637215" cy="4206240"/>
           </a:xfrm>
           <a:prstGeom prst="rect">
@@ -5219,7 +5327,7 @@
               <a:spcAft>
                 <a:spcPts val="1400"/>
               </a:spcAft>
-              <a:defRPr sz="1900" b="0">
+              <a:defRPr sz="1400" b="0">
                 <a:solidFill>
                   <a:srgbClr val="1A1D21"/>
                 </a:solidFill>
@@ -5227,7 +5335,7 @@
               </a:defRPr>
             </a:pPr>
             <a:r>
-              <a:t>·  PK1 — Strategjitë janë të sakta kur ndezin, por e humbin shumicën e rasteve.</a:t>
+              <a:t>·  Të ripeshuara: 63% të pranueshme për një zhvillues, zakonisht pas një ndreqjeje të vogël.</a:t>
             </a:r>
           </a:p>
           <a:p>
@@ -5235,7 +5343,7 @@
               <a:spcAft>
                 <a:spcPts val="1400"/>
               </a:spcAft>
-              <a:defRPr sz="1900">
+              <a:defRPr sz="1400">
                 <a:solidFill>
                   <a:srgbClr val="1A1D21"/>
                 </a:solidFill>
@@ -5243,23 +5351,7 @@
               </a:defRPr>
             </a:pPr>
             <a:r>
-              <a:t>·  PK2 — Po. Modeli i tejkalon pragjet fikse te të katër erërat, mbi të njëjtën ndarje dhe me të njëjtin kod pikëzimi.</a:t>
-            </a:r>
-          </a:p>
-          <a:p>
-            <a:pPr>
-              <a:spcAft>
-                <a:spcPts val="1400"/>
-              </a:spcAft>
-              <a:defRPr sz="1900">
-                <a:solidFill>
-                  <a:srgbClr val="1A1D21"/>
-                </a:solidFill>
-                <a:latin typeface="Segoe UI"/>
-              </a:defRPr>
-            </a:pPr>
-            <a:r>
-              <a:t>·  PK3 — Pjesërisht. Rishkrimet e aplikuara u verifikuan me kompilator dhe u rimatën; ruajtja e sjelljes mbetet jashtë pyetjes dhe thuhet si kufizim.</a:t>
+              <a:t>·  Introduce Parameter Object e heq erën nga matja, jo nga kodi: lista e gjatë kalon te konstruktori.</a:t>
             </a:r>
           </a:p>
         </p:txBody>
@@ -5313,20 +5405,7 @@
               </a:defRPr>
             </a:pPr>
             <a:r>
-              <a:t>Kufizimet</a:t>
-            </a:r>
-          </a:p>
-          <a:p>
-            <a:pPr>
-              <a:defRPr sz="1400">
-                <a:solidFill>
-                  <a:srgbClr val="838D99"/>
-                </a:solidFill>
-                <a:latin typeface="Segoe UI"/>
-              </a:defRPr>
-            </a:pPr>
-            <a:r>
-              <a:t>Të raportuara, jo të zbutura</a:t>
+              <a:t>Përgjigjet</a:t>
             </a:r>
           </a:p>
         </p:txBody>
@@ -5365,7 +5444,7 @@
               </a:defRPr>
             </a:pPr>
             <a:r>
-              <a:t>·  E vërteta bazë është subjektive dhe rishikuesit nuk pajtohen mes tyre.</a:t>
+              <a:t>·  PK1 — Strategjitë janë të sakta kur ndezin, por e humbin shumicën e rasteve.</a:t>
             </a:r>
           </a:p>
           <a:p>
@@ -5381,7 +5460,7 @@
               </a:defRPr>
             </a:pPr>
             <a:r>
-              <a:t>·  Analiza është statike dhe nuk zgjidh tipa: varësitë semantike trajtohen konservativisht.</a:t>
+              <a:t>·  PK2 — Po. Modeli i tejkalon pragjet fikse te të katër erërat, mbi të njëjtën ndarje dhe me të njëjtin kod pikëzimi.</a:t>
             </a:r>
           </a:p>
           <a:p>
@@ -5397,39 +5476,7 @@
               </a:defRPr>
             </a:pPr>
             <a:r>
-              <a:t>·  Ashpërsia e derivuar u krahasua me atë të rishikuesve, rezultati doli negativ, dhe pretendimi u hoq.</a:t>
-            </a:r>
-          </a:p>
-          <a:p>
-            <a:pPr>
-              <a:spcAft>
-                <a:spcPts val="1400"/>
-              </a:spcAft>
-              <a:defRPr sz="1900">
-                <a:solidFill>
-                  <a:srgbClr val="1A1D21"/>
-                </a:solidFill>
-                <a:latin typeface="Segoe UI"/>
-              </a:defRPr>
-            </a:pPr>
-            <a:r>
-              <a:t>·  Sjellja e kodit të rishkruar mbetet e paverifikuar.</a:t>
-            </a:r>
-          </a:p>
-          <a:p>
-            <a:pPr>
-              <a:spcAft>
-                <a:spcPts val="1400"/>
-              </a:spcAft>
-              <a:defRPr sz="1900">
-                <a:solidFill>
-                  <a:srgbClr val="1A1D21"/>
-                </a:solidFill>
-                <a:latin typeface="Segoe UI"/>
-              </a:defRPr>
-            </a:pPr>
-            <a:r>
-              <a:t>·  Nuk ka krahasim me mjete ekzistuese: kontributi është krahasueshmëria e brendshme mes A-së dhe B-së.</a:t>
+              <a:t>·  PK3 — Pjesërisht. Rishkrimet u verifikuan me kompilator dhe u rimatën; struktura përmirësohet te Guard Clauses dhe Extract Method, jo te Introduce Parameter Object. Sjellja nuk u mat.</a:t>
             </a:r>
           </a:p>
         </p:txBody>
@@ -5483,7 +5530,20 @@
               </a:defRPr>
             </a:pPr>
             <a:r>
-              <a:t>Kontributi</a:t>
+              <a:t>Kufizimet</a:t>
+            </a:r>
+          </a:p>
+          <a:p>
+            <a:pPr>
+              <a:defRPr sz="1400">
+                <a:solidFill>
+                  <a:srgbClr val="838D99"/>
+                </a:solidFill>
+                <a:latin typeface="Segoe UI"/>
+              </a:defRPr>
+            </a:pPr>
+            <a:r>
+              <a:t>Të raportuara, jo të zbutura</a:t>
             </a:r>
           </a:p>
         </p:txBody>
@@ -5522,7 +5582,7 @@
               </a:defRPr>
             </a:pPr>
             <a:r>
-              <a:t>·  Dy qasje detektimi të vlerësuara mbi të njëjtin korpus me të njëjtin kod pikëzimi, me ndarje të grupuar dhe të deklaruar.</a:t>
+              <a:t>·  E vërteta bazë është subjektive dhe rishikuesit nuk pajtohen mes tyre.</a:t>
             </a:r>
           </a:p>
           <a:p>
@@ -5538,7 +5598,7 @@
               </a:defRPr>
             </a:pPr>
             <a:r>
-              <a:t>·  Lidhja mes detektimit dhe refaktorimit e matur empirikisht: sa nga rastet e gjetura arrijnë të transformohen vërtet.</a:t>
+              <a:t>·  Analiza është statike dhe nuk zgjidh tipa: varësitë semantike trajtohen konservativisht.</a:t>
             </a:r>
           </a:p>
           <a:p>
@@ -5554,7 +5614,7 @@
               </a:defRPr>
             </a:pPr>
             <a:r>
-              <a:t>·  Rezultatet negative të raportuara, jo të fshehura.</a:t>
+              <a:t>·  Ashpërsia e derivuar u krahasua me atë të rishikuesve, rezultati doli negativ, dhe pretendimi u hoq.</a:t>
             </a:r>
           </a:p>
           <a:p>
@@ -5570,7 +5630,23 @@
               </a:defRPr>
             </a:pPr>
             <a:r>
-              <a:t>·  Çdo shifër e riprodhueshme nga një skript, dhe riprodhimi u vu në provë.</a:t>
+              <a:t>·  Sjellja e kodit të rishkruar mbetet e paverifikuar.</a:t>
+            </a:r>
+          </a:p>
+          <a:p>
+            <a:pPr>
+              <a:spcAft>
+                <a:spcPts val="1400"/>
+              </a:spcAft>
+              <a:defRPr sz="1900">
+                <a:solidFill>
+                  <a:srgbClr val="1A1D21"/>
+                </a:solidFill>
+                <a:latin typeface="Segoe UI"/>
+              </a:defRPr>
+            </a:pPr>
+            <a:r>
+              <a:t>·  Cilësia e rishkrimeve u gjykua nga një rishikues i vetëm.</a:t>
             </a:r>
           </a:p>
         </p:txBody>
@@ -5601,6 +5677,147 @@
         </p:nvSpPr>
         <p:spPr>
           <a:xfrm>
+            <a:off x="777240" y="457200"/>
+            <a:ext cx="10637215" cy="914400"/>
+          </a:xfrm>
+          <a:prstGeom prst="rect">
+            <a:avLst/>
+          </a:prstGeom>
+          <a:noFill/>
+        </p:spPr>
+        <p:txBody>
+          <a:bodyPr wrap="square">
+            <a:spAutoFit/>
+          </a:bodyPr>
+          <a:lstStyle/>
+          <a:p>
+            <a:pPr>
+              <a:defRPr sz="3400" b="0">
+                <a:solidFill>
+                  <a:srgbClr val="1A1D21"/>
+                </a:solidFill>
+                <a:latin typeface="Times New Roman"/>
+              </a:defRPr>
+            </a:pPr>
+            <a:r>
+              <a:t>Kontributi</a:t>
+            </a:r>
+          </a:p>
+        </p:txBody>
+      </p:sp>
+      <p:sp>
+        <p:nvSpPr>
+          <p:cNvPr id="3" name="TextBox 2"/>
+          <p:cNvSpPr txBox="1"/>
+          <p:nvPr/>
+        </p:nvSpPr>
+        <p:spPr>
+          <a:xfrm>
+            <a:off x="777240" y="1737360"/>
+            <a:ext cx="10637215" cy="4206240"/>
+          </a:xfrm>
+          <a:prstGeom prst="rect">
+            <a:avLst/>
+          </a:prstGeom>
+          <a:noFill/>
+        </p:spPr>
+        <p:txBody>
+          <a:bodyPr wrap="square">
+            <a:spAutoFit/>
+          </a:bodyPr>
+          <a:lstStyle/>
+          <a:p>
+            <a:pPr>
+              <a:spcAft>
+                <a:spcPts val="1400"/>
+              </a:spcAft>
+              <a:defRPr sz="1900" b="0">
+                <a:solidFill>
+                  <a:srgbClr val="1A1D21"/>
+                </a:solidFill>
+                <a:latin typeface="Segoe UI"/>
+              </a:defRPr>
+            </a:pPr>
+            <a:r>
+              <a:t>·  Dy qasje detektimi të vlerësuara mbi të njëjtin korpus me të njëjtin kod pikëzimi, me ndarje të grupuar dhe të deklaruar.</a:t>
+            </a:r>
+          </a:p>
+          <a:p>
+            <a:pPr>
+              <a:spcAft>
+                <a:spcPts val="1400"/>
+              </a:spcAft>
+              <a:defRPr sz="1900">
+                <a:solidFill>
+                  <a:srgbClr val="1A1D21"/>
+                </a:solidFill>
+                <a:latin typeface="Segoe UI"/>
+              </a:defRPr>
+            </a:pPr>
+            <a:r>
+              <a:t>·  Lidhja mes detektimit dhe refaktorimit e matur empirikisht: sa nga rastet e gjetura arrijnë të transformohen vërtet.</a:t>
+            </a:r>
+          </a:p>
+          <a:p>
+            <a:pPr>
+              <a:spcAft>
+                <a:spcPts val="1400"/>
+              </a:spcAft>
+              <a:defRPr sz="1900">
+                <a:solidFill>
+                  <a:srgbClr val="1A1D21"/>
+                </a:solidFill>
+                <a:latin typeface="Segoe UI"/>
+              </a:defRPr>
+            </a:pPr>
+            <a:r>
+              <a:t>·  Rezultatet negative të raportuara, jo të fshehura.</a:t>
+            </a:r>
+          </a:p>
+          <a:p>
+            <a:pPr>
+              <a:spcAft>
+                <a:spcPts val="1400"/>
+              </a:spcAft>
+              <a:defRPr sz="1900">
+                <a:solidFill>
+                  <a:srgbClr val="1A1D21"/>
+                </a:solidFill>
+                <a:latin typeface="Segoe UI"/>
+              </a:defRPr>
+            </a:pPr>
+            <a:r>
+              <a:t>·  Çdo shifër e riprodhueshme nga një skript, dhe riprodhimi u vu në provë.</a:t>
+            </a:r>
+          </a:p>
+        </p:txBody>
+      </p:sp>
+    </p:spTree>
+  </p:cSld>
+  <p:clrMapOvr>
+    <a:masterClrMapping/>
+  </p:clrMapOvr>
+</p:sld>
+</file>
+
+<file path=ppt/slides/slide16.xml><?xml version="1.0" encoding="utf-8"?>
+<p:sld xmlns:a="http://schemas.openxmlformats.org/drawingml/2006/main" xmlns:p="http://schemas.openxmlformats.org/presentationml/2006/main" xmlns:r="http://schemas.openxmlformats.org/officeDocument/2006/relationships">
+  <p:cSld>
+    <p:spTree>
+      <p:nvGrpSpPr>
+        <p:cNvPr id="1" name=""/>
+        <p:cNvGrpSpPr/>
+        <p:nvPr/>
+      </p:nvGrpSpPr>
+      <p:grpSpPr/>
+      <p:sp>
+        <p:nvSpPr>
+          <p:cNvPr id="2" name="TextBox 1"/>
+          <p:cNvSpPr txBox="1"/>
+          <p:nvPr/>
+        </p:nvSpPr>
+        <p:spPr>
+          <a:xfrm>
             <a:off x="777240" y="2743200"/>
             <a:ext cx="10637215" cy="914400"/>
           </a:xfrm>
@@ -5673,7 +5890,7 @@
 </p:sld>
 </file>
 
-<file path=ppt/slides/slide16.xml><?xml version="1.0" encoding="utf-8"?>
+<file path=ppt/slides/slide17.xml><?xml version="1.0" encoding="utf-8"?>
 <p:sld xmlns:a="http://schemas.openxmlformats.org/drawingml/2006/main" xmlns:p="http://schemas.openxmlformats.org/presentationml/2006/main" xmlns:r="http://schemas.openxmlformats.org/officeDocument/2006/relationships">
   <p:cSld>
     <p:spTree>
@@ -5751,7 +5968,7 @@
 </p:sld>
 </file>
 
-<file path=ppt/slides/slide17.xml><?xml version="1.0" encoding="utf-8"?>
+<file path=ppt/slides/slide18.xml><?xml version="1.0" encoding="utf-8"?>
 <p:sld xmlns:a="http://schemas.openxmlformats.org/drawingml/2006/main" xmlns:p="http://schemas.openxmlformats.org/presentationml/2006/main" xmlns:r="http://schemas.openxmlformats.org/officeDocument/2006/relationships">
   <p:cSld>
     <p:spTree>
@@ -7243,6 +7460,22 @@
             </a:pPr>
             <a:r>
               <a:t>·  Kur strategjia ndez, zakonisht ka të drejtë. Por ndez rrallë.</a:t>
+            </a:r>
+          </a:p>
+          <a:p>
+            <a:pPr>
+              <a:spcAft>
+                <a:spcPts val="1400"/>
+              </a:spcAft>
+              <a:defRPr sz="1400">
+                <a:solidFill>
+                  <a:srgbClr val="1A1D21"/>
+                </a:solidFill>
+                <a:latin typeface="Segoe UI"/>
+              </a:defRPr>
+            </a:pPr>
+            <a:r>
+              <a:t>·  PMD-ja, me të njëjtat strategji dhe pragjet e veta, nuk del më mirë në asnjë krahasim.</a:t>
             </a:r>
           </a:p>
         </p:txBody>

</xml_diff>

<commit_message>
Ndërto punimin dhe prezantimin me rezultatet e rimatura
Abstrakti hyn sërish në një faqe; pohimi për PMD-në lexohet me intervalin e besimit.
</commit_message>
<xml_diff>
--- a/docs/thesis/Prezantimi_Florent_Latifi.pptx
+++ b/docs/thesis/Prezantimi_Florent_Latifi.pptx
@@ -1639,7 +1639,7 @@
           <a:lstStyle/>
           <a:p>
             <a:r>
-              <a:t>Modeli fiton te të katër erërat, dhe përparësia mbetet mbi zeron edhe me intervale besimi të grupuara sipas depos.</a:t>
+              <a:t>Modeli del më lart te të katër erërat; me intervale besimi të grupuara sipas depos, përparësia mbetet mbi zero te tri prej tyre, por jo te Feature Envy.</a:t>
             </a:r>
           </a:p>
         </p:txBody>
@@ -5293,8 +5293,8 @@
         </p:blipFill>
         <p:spPr>
           <a:xfrm>
-            <a:off x="2565333" y="1737360"/>
-            <a:ext cx="7061028" cy="3108960"/>
+            <a:off x="2571307" y="1737360"/>
+            <a:ext cx="7049080" cy="3108960"/>
           </a:xfrm>
           <a:prstGeom prst="rect">
             <a:avLst/>
@@ -5460,7 +5460,7 @@
               </a:defRPr>
             </a:pPr>
             <a:r>
-              <a:t>·  PK2 — Po. Modeli i tejkalon pragjet fikse te të katër erërat, mbi të njëjtën ndarje dhe me të njëjtin kod pikëzimi.</a:t>
+              <a:t>·  PK2 — Po, te tri nga katër erërat. Modeli i tejkalon pragjet fikse mbi të njëjtën ndarje; te Feature Envy dallimi nuk dallohet nga zeroja.</a:t>
             </a:r>
           </a:p>
           <a:p>
@@ -5582,7 +5582,7 @@
               </a:defRPr>
             </a:pPr>
             <a:r>
-              <a:t>·  E vërteta bazë është subjektive dhe rishikuesit nuk pajtohen mes tyre.</a:t>
+              <a:t>·  E vërteta bazë është subjektive: rishikuesit pajtohen vetëm mesatarisht, dhe për Feature Envy aspak.</a:t>
             </a:r>
           </a:p>
           <a:p>
@@ -6171,7 +6171,7 @@
               </a:defRPr>
             </a:pPr>
             <a:r>
-              <a:t>·  Vetë zhvilluesit profesionistë nuk pajtohen mes tyre për një të katërtën e mostrave.</a:t>
+              <a:t>·  Vetë zhvilluesit profesionistë nuk pajtohen mes tyre në një pjesë të madhe të gjykimeve, dhe për Feature Envy pothuajse aspak.</a:t>
             </a:r>
           </a:p>
           <a:p>
@@ -6569,7 +6569,7 @@
               </a:defRPr>
             </a:pPr>
             <a:r>
-              <a:t>4 534</a:t>
+              <a:t>9 046</a:t>
             </a:r>
           </a:p>
           <a:p>
@@ -7102,7 +7102,7 @@
                         </a:defRPr>
                       </a:pPr>
                       <a:r>
-                        <a:t>0.814</a:t>
+                        <a:t>0.816</a:t>
                       </a:r>
                     </a:p>
                   </a:txBody>
@@ -7119,7 +7119,7 @@
                         </a:defRPr>
                       </a:pPr>
                       <a:r>
-                        <a:t>0.100</a:t>
+                        <a:t>0.174</a:t>
                       </a:r>
                     </a:p>
                   </a:txBody>
@@ -7136,7 +7136,7 @@
                         </a:defRPr>
                       </a:pPr>
                       <a:r>
-                        <a:t>0.178</a:t>
+                        <a:t>0.286</a:t>
                       </a:r>
                     </a:p>
                   </a:txBody>
@@ -7153,7 +7153,7 @@
                         </a:defRPr>
                       </a:pPr>
                       <a:r>
-                        <a:t>0.232</a:t>
+                        <a:t>0.336</a:t>
                       </a:r>
                     </a:p>
                   </a:txBody>
@@ -7189,7 +7189,7 @@
                         </a:defRPr>
                       </a:pPr>
                       <a:r>
-                        <a:t>0.757</a:t>
+                        <a:t>0.765</a:t>
                       </a:r>
                     </a:p>
                   </a:txBody>
@@ -7206,7 +7206,7 @@
                         </a:defRPr>
                       </a:pPr>
                       <a:r>
-                        <a:t>0.150</a:t>
+                        <a:t>0.230</a:t>
                       </a:r>
                     </a:p>
                   </a:txBody>
@@ -7223,7 +7223,7 @@
                         </a:defRPr>
                       </a:pPr>
                       <a:r>
-                        <a:t>0.251</a:t>
+                        <a:t>0.353</a:t>
                       </a:r>
                     </a:p>
                   </a:txBody>
@@ -7240,7 +7240,7 @@
                         </a:defRPr>
                       </a:pPr>
                       <a:r>
-                        <a:t>0.275</a:t>
+                        <a:t>0.367</a:t>
                       </a:r>
                     </a:p>
                   </a:txBody>
@@ -7276,7 +7276,7 @@
                         </a:defRPr>
                       </a:pPr>
                       <a:r>
-                        <a:t>0.520</a:t>
+                        <a:t>0.413</a:t>
                       </a:r>
                     </a:p>
                   </a:txBody>
@@ -7293,7 +7293,7 @@
                         </a:defRPr>
                       </a:pPr>
                       <a:r>
-                        <a:t>0.181</a:t>
+                        <a:t>0.188</a:t>
                       </a:r>
                     </a:p>
                   </a:txBody>
@@ -7310,7 +7310,7 @@
                         </a:defRPr>
                       </a:pPr>
                       <a:r>
-                        <a:t>0.268</a:t>
+                        <a:t>0.258</a:t>
                       </a:r>
                     </a:p>
                   </a:txBody>
@@ -7327,7 +7327,7 @@
                         </a:defRPr>
                       </a:pPr>
                       <a:r>
-                        <a:t>0.271</a:t>
+                        <a:t>0.243</a:t>
                       </a:r>
                     </a:p>
                   </a:txBody>
@@ -7363,7 +7363,7 @@
                         </a:defRPr>
                       </a:pPr>
                       <a:r>
-                        <a:t>0.872</a:t>
+                        <a:t>0.888</a:t>
                       </a:r>
                     </a:p>
                   </a:txBody>
@@ -7380,7 +7380,7 @@
                         </a:defRPr>
                       </a:pPr>
                       <a:r>
-                        <a:t>0.440</a:t>
+                        <a:t>0.470</a:t>
                       </a:r>
                     </a:p>
                   </a:txBody>
@@ -7397,7 +7397,7 @@
                         </a:defRPr>
                       </a:pPr>
                       <a:r>
-                        <a:t>0.585</a:t>
+                        <a:t>0.615</a:t>
                       </a:r>
                     </a:p>
                   </a:txBody>
@@ -7414,7 +7414,7 @@
                         </a:defRPr>
                       </a:pPr>
                       <a:r>
-                        <a:t>0.580</a:t>
+                        <a:t>0.617</a:t>
                       </a:r>
                     </a:p>
                   </a:txBody>
@@ -7475,7 +7475,7 @@
               </a:defRPr>
             </a:pPr>
             <a:r>
-              <a:t>·  PMD-ja, me të njëjtat strategji dhe pragjet e veta, nuk del më mirë në asnjë krahasim.</a:t>
+              <a:t>·  PMD-ja, me të njëjtat strategji dhe pragjet e veta, nuk del përpara në asnjë krahasim; te Long Method dhe te Blob me madhësinë del pas.</a:t>
             </a:r>
           </a:p>
         </p:txBody>
@@ -7761,7 +7761,7 @@
                         </a:defRPr>
                       </a:pPr>
                       <a:r>
-                        <a:t>0.232</a:t>
+                        <a:t>0.336</a:t>
                       </a:r>
                     </a:p>
                   </a:txBody>
@@ -7778,7 +7778,7 @@
                         </a:defRPr>
                       </a:pPr>
                       <a:r>
-                        <a:t>0.488</a:t>
+                        <a:t>0.539</a:t>
                       </a:r>
                     </a:p>
                   </a:txBody>
@@ -7795,7 +7795,7 @@
                         </a:defRPr>
                       </a:pPr>
                       <a:r>
-                        <a:t>0.022</a:t>
+                        <a:t>0.312</a:t>
                       </a:r>
                     </a:p>
                   </a:txBody>
@@ -7831,7 +7831,7 @@
                         </a:defRPr>
                       </a:pPr>
                       <a:r>
-                        <a:t>0.275</a:t>
+                        <a:t>0.367</a:t>
                       </a:r>
                     </a:p>
                   </a:txBody>
@@ -7848,7 +7848,7 @@
                         </a:defRPr>
                       </a:pPr>
                       <a:r>
-                        <a:t>0.498</a:t>
+                        <a:t>0.473</a:t>
                       </a:r>
                     </a:p>
                   </a:txBody>
@@ -7865,7 +7865,7 @@
                         </a:defRPr>
                       </a:pPr>
                       <a:r>
-                        <a:t>0.031</a:t>
+                        <a:t>0.396</a:t>
                       </a:r>
                     </a:p>
                   </a:txBody>
@@ -7901,7 +7901,7 @@
                         </a:defRPr>
                       </a:pPr>
                       <a:r>
-                        <a:t>0.271</a:t>
+                        <a:t>0.243</a:t>
                       </a:r>
                     </a:p>
                   </a:txBody>
@@ -7918,7 +7918,7 @@
                         </a:defRPr>
                       </a:pPr>
                       <a:r>
-                        <a:t>0.696</a:t>
+                        <a:t>0.321</a:t>
                       </a:r>
                     </a:p>
                   </a:txBody>
@@ -7935,7 +7935,7 @@
                         </a:defRPr>
                       </a:pPr>
                       <a:r>
-                        <a:t>0.238</a:t>
+                        <a:t>-0.071</a:t>
                       </a:r>
                     </a:p>
                   </a:txBody>
@@ -7971,7 +7971,7 @@
                         </a:defRPr>
                       </a:pPr>
                       <a:r>
-                        <a:t>0.580</a:t>
+                        <a:t>0.617</a:t>
                       </a:r>
                     </a:p>
                   </a:txBody>
@@ -7988,7 +7988,7 @@
                         </a:defRPr>
                       </a:pPr>
                       <a:r>
-                        <a:t>0.724</a:t>
+                        <a:t>0.723</a:t>
                       </a:r>
                     </a:p>
                   </a:txBody>
@@ -8005,7 +8005,7 @@
                         </a:defRPr>
                       </a:pPr>
                       <a:r>
-                        <a:t>0.189</a:t>
+                        <a:t>0.567</a:t>
                       </a:r>
                     </a:p>
                   </a:txBody>
@@ -8050,7 +8050,7 @@
               </a:defRPr>
             </a:pPr>
             <a:r>
-              <a:t>·  Vetë rishikuesit pajtohen mes tyre me MCC 0.022–0.238. Kjo i vendos të gjitha shifrat e mësipërme në një shkallë tjetër.</a:t>
+              <a:t>·  Vetë rishikuesit pajtohen mes tyre me MCC -0.071–0.567. Kjo i vendos të gjitha shifrat e mësipërme në një shkallë tjetër.</a:t>
             </a:r>
           </a:p>
         </p:txBody>

</xml_diff>